<commit_message>
chore: eliminar archivo no deseado
</commit_message>
<xml_diff>
--- a/Work Sample_Orlando_Chavez.pptx
+++ b/Work Sample_Orlando_Chavez.pptx
@@ -115,6 +115,11 @@
       </a:defRPr>
     </a:lvl9pPr>
   </p:defaultTextStyle>
+  <p:extLst>
+    <p:ext uri="{EFAFB233-063F-42B5-8137-9DF3F51BA10A}">
+      <p15:sldGuideLst xmlns:p15="http://schemas.microsoft.com/office/powerpoint/2012/main"/>
+    </p:ext>
+  </p:extLst>
 </p:presentation>
 </file>
 
@@ -11005,7 +11010,7 @@
       </p:grpSpPr>
       <p:pic>
         <p:nvPicPr>
-          <p:cNvPr id="4" name="Imagen 3"/>
+          <p:cNvPr id="2" name="Imagen 1"/>
           <p:cNvPicPr>
             <a:picLocks noChangeAspect="1"/>
           </p:cNvPicPr>
@@ -11025,8 +11030,8 @@
         </p:blipFill>
         <p:spPr>
           <a:xfrm>
-            <a:off x="418708" y="586507"/>
-            <a:ext cx="9038103" cy="5364945"/>
+            <a:off x="1026188" y="536330"/>
+            <a:ext cx="10049264" cy="5597973"/>
           </a:xfrm>
           <a:prstGeom prst="rect">
             <a:avLst/>
@@ -23574,15 +23579,6 @@
               </a:rPr>
               <a:t>Negociar con áreas comerciales o de transporte un corrimiento menor en los horarios de inyección de volumen para aplanar los picos de demanda.</a:t>
             </a:r>
-            <a:endParaRPr kumimoji="0" lang="es-MX" altLang="es-MX" sz="1400" b="0" i="0" u="none" strike="noStrike" cap="none" normalizeH="0" baseline="0" dirty="0" smtClean="0">
-              <a:ln>
-                <a:noFill/>
-              </a:ln>
-              <a:solidFill>
-                <a:schemeClr val="tx1"/>
-              </a:solidFill>
-              <a:effectLst/>
-            </a:endParaRPr>
           </a:p>
         </p:txBody>
       </p:sp>

</xml_diff>